<commit_message>
Make lesson 7's impurity equation readable on a projector
Every equation image is rendered at a fixed size and then shrunk to fit the
slide's width, so a long line ends up with small glyphs and the nested
fractions go first. This one was the worst in the course: 0.57 inches tall
on screen, 54% of the size it was drawn at, with m_L/m_P inside it.

Writing G_P, G_L, G_R for G(parent), G(left), G(right) takes it to 88% -
half again as large - and loses nothing: the handout's own section 2.2
already names those three groups and the notation table already defines
m_P, m_L and m_R. The notes now say what the subscripts are before the
formula is read.

Co-Authored-By: Claude Opus 5 <noreply@anthropic.com>
Claude-Session: https://claude.ai/code/session_01AGVdtkDgZ58kt68DhqnwXC
</commit_message>
<xml_diff>
--- a/Lessons/07_trees_and_ensembles/Slides/trees_and_ensembles_slides.pptx
+++ b/Lessons/07_trees_and_ensembles/Slides/trees_and_ensembles_slides.pptx
@@ -802,7 +802,7 @@
             </a:pPr>
             <a:r>
               <a:rPr/>
-              <a:t>The two m terms are the sizes of the left and right children, and they add to the parent’s. Read it as: what the parent’s impurity was, minus what is left after the split, weighted by how the group was divided. The tree keeps whichever candidate split makes ΔG largest.</a:t>
+              <a:t>Say what the subscripts are before reading the formula: P, L and R are the parent group and its two children, the same three the handout names in words, and the m terms are how many examples are in each. The two m terms are the sizes of the left and right children, and they add to the parent’s. Read it as: what the parent’s impurity was, minus what is left after the split, weighted by how the group was divided. The tree keeps whichever candidate split makes ΔG largest.</a:t>
             </a:r>
           </a:p>
           <a:p>
@@ -9465,7 +9465,7 @@
       </p:sp>
       <p:pic>
         <p:nvPicPr>
-          <p:cNvPr descr="eq_77488865aa.png" id="0" name="Picture 1"/>
+          <p:cNvPr descr="eq_e6f67b5356.png" id="0" name="Picture 1"/>
           <p:cNvPicPr>
             <a:picLocks noGrp="1" noChangeAspect="1"/>
           </p:cNvPicPr>
@@ -9479,8 +9479,8 @@
         </p:blipFill>
         <p:spPr bwMode="auto">
           <a:xfrm>
-            <a:off x="457200" y="2554089"/>
-            <a:ext cx="8229600" cy="584200"/>
+            <a:off x="457204" y="2363590"/>
+            <a:ext cx="8229591" cy="965199"/>
           </a:xfrm>
           <a:prstGeom prst="rect">
             <a:avLst/>

</xml_diff>

<commit_message>
Check lesson 7's from-scratch tree prediction by prediction
The comparison with scikit-learn reported equal accuracy "to the fourth
decimal place", which two different trees can share while misclassifying
different applicants. Notebook 1 now also counts identical predictions -
100.0% at every depth - and says why the check runs on the training data:
it tests the code, not the model. The slide, its notes, the handout's
worked example and summary, and the quiz answer say the same.

Co-Authored-By: Claude Opus 5.5 <noreply@anthropic.com>
</commit_message>
<xml_diff>
--- a/Lessons/07_trees_and_ensembles/Slides/trees_and_ensembles_slides.pptx
+++ b/Lessons/07_trees_and_ensembles/Slides/trees_and_ensembles_slides.pptx
@@ -1329,6 +1329,20 @@
             <a:r>
               <a:rPr/>
               <a:t>This is the check notebook 1 runs live, and it matters for trust rather than for novelty: once the from-scratch version is shown to agree with scikit-learn exactly, every later result in the lesson - obtained with scikit-learn - inherits that confidence.</a:t>
+            </a:r>
+          </a:p>
+          <a:p>
+            <a:pPr lvl="0" indent="0" marL="0">
+              <a:buNone/>
+            </a:pPr>
+          </a:p>
+          <a:p>
+            <a:pPr lvl="0" indent="0" marL="0">
+              <a:buNone/>
+            </a:pPr>
+            <a:r>
+              <a:rPr/>
+              <a:t>Two questions to pre-empt. Why predictions and not accuracy? Because two different trees can get the same number of applicants wrong while getting different applicants wrong; identical predictions, one by one, rule that out. And why on the training data, after lesson 5? Because this checks the code, not the model: the question is whether two programs build the same tree from the same rows, and the rows they learned from are exactly the right ones to ask it on. No accuracy here is a claim about new applicants.</a:t>
             </a:r>
           </a:p>
           <a:p>
@@ -10424,7 +10438,7 @@
             <a:pPr lvl="0"/>
             <a:r>
               <a:rPr/>
-              <a:t>The from-scratch implementation agrees with scikit-learn’s </a:t>
+              <a:t>The from-scratch implementation and scikit-learn’s </a:t>
             </a:r>
             <a:r>
               <a:rPr>
@@ -10434,15 +10448,15 @@
             </a:r>
             <a:r>
               <a:rPr/>
-              <a:t> to the </a:t>
+              <a:t> make </a:t>
             </a:r>
             <a:r>
               <a:rPr b="1"/>
-              <a:t>fourth decimal place</a:t>
-            </a:r>
-            <a:r>
-              <a:rPr/>
-              <a:t> of resulting accuracy, at every depth tested</a:t>
+              <a:t>the same prediction for all 1,200 applicants</a:t>
+            </a:r>
+            <a:r>
+              <a:rPr/>
+              <a:t>, at every depth tested</a:t>
             </a:r>
           </a:p>
           <a:p>

</xml_diff>